<commit_message>
Lock the README and the three status slides to the same cut.
The alignment check now fails if the talk insert drifts from the dialect page.

Co-authored-by: Johnson.Chen <joy6677@outlook.com>
</commit_message>
<xml_diff>
--- a/docs/design/goal-alignment-v1-status.pptx
+++ b/docs/design/goal-alignment-v1-status.pptx
@@ -6,6 +6,8 @@
   </p:sldMasterIdLst>
   <p:sldIdLst>
     <p:sldId id="256" r:id="rId7"/>
+    <p:sldId id="257" r:id="rId8"/>
+    <p:sldId id="258" r:id="rId9"/>
   </p:sldIdLst>
   <p:sldSz cx="12191695" cy="6858000" type="screen4x3"/>
   <p:notesSz cx="6858000" cy="9144000"/>
@@ -3183,7 +3185,7 @@
         <p:spPr>
           <a:xfrm>
             <a:off x="438912" y="256032"/>
-            <a:ext cx="11155680" cy="310896"/>
+            <a:ext cx="11155680" cy="292608"/>
           </a:xfrm>
           <a:prstGeom prst="rect">
             <a:avLst/>
@@ -3191,12 +3193,14 @@
           <a:noFill/>
         </p:spPr>
         <p:txBody>
-          <a:bodyPr wrap="square"/>
+          <a:bodyPr wrap="square">
+            <a:spAutoFit/>
+          </a:bodyPr>
           <a:lstStyle/>
           <a:p>
             <a:pPr algn="l">
               <a:spcAft>
-                <a:spcPts val="400"/>
+                <a:spcPts val="600"/>
               </a:spcAft>
             </a:pPr>
             <a:r>
@@ -3206,7 +3210,7 @@
                 </a:solidFill>
                 <a:latin typeface="Microsoft YaHei"/>
               </a:rPr>
-              <a:t>现状  ·  与仓库对齐</a:t>
+              <a:t>现状  1 / 3    方向与交付</a:t>
             </a:r>
           </a:p>
         </p:txBody>
@@ -3220,7 +3224,7 @@
         <p:spPr>
           <a:xfrm>
             <a:off x="438912" y="566928"/>
-            <a:ext cx="11155680" cy="502920"/>
+            <a:ext cx="11155680" cy="640080"/>
           </a:xfrm>
           <a:prstGeom prst="rect">
             <a:avLst/>
@@ -3228,12 +3232,14 @@
           <a:noFill/>
         </p:spPr>
         <p:txBody>
-          <a:bodyPr wrap="square"/>
+          <a:bodyPr wrap="square">
+            <a:spAutoFit/>
+          </a:bodyPr>
           <a:lstStyle/>
           <a:p>
             <a:pPr algn="l">
               <a:spcAft>
-                <a:spcPts val="400"/>
+                <a:spcPts val="600"/>
               </a:spcAft>
             </a:pPr>
             <a:r>
@@ -3256,7 +3262,7 @@
         </p:nvSpPr>
         <p:spPr>
           <a:xfrm>
-            <a:off x="438912" y="1115568"/>
+            <a:off x="438912" y="1234440"/>
             <a:ext cx="11155680" cy="365760"/>
           </a:xfrm>
           <a:prstGeom prst="rect">
@@ -3265,16 +3271,18 @@
           <a:noFill/>
         </p:spPr>
         <p:txBody>
-          <a:bodyPr wrap="square"/>
+          <a:bodyPr wrap="square">
+            <a:spAutoFit/>
+          </a:bodyPr>
           <a:lstStyle/>
           <a:p>
             <a:pPr algn="l">
               <a:spcAft>
-                <a:spcPts val="400"/>
+                <a:spcPts val="600"/>
               </a:spcAft>
             </a:pPr>
             <a:r>
-              <a:rPr sz="1500" b="0">
+              <a:rPr sz="1600" b="0">
                 <a:solidFill>
                   <a:srgbClr val="A8B3C7"/>
                 </a:solidFill>
@@ -3293,8 +3301,8 @@
         </p:nvSpPr>
         <p:spPr>
           <a:xfrm>
-            <a:off x="438912" y="1691640"/>
-            <a:ext cx="5532120" cy="4160520"/>
+            <a:off x="438912" y="1783080"/>
+            <a:ext cx="5532120" cy="4023360"/>
           </a:xfrm>
           <a:prstGeom prst="rect">
             <a:avLst/>
@@ -3336,8 +3344,8 @@
         </p:nvSpPr>
         <p:spPr>
           <a:xfrm>
-            <a:off x="6172200" y="1691640"/>
-            <a:ext cx="5532120" cy="4160520"/>
+            <a:off x="6172200" y="1783080"/>
+            <a:ext cx="5532120" cy="4023360"/>
           </a:xfrm>
           <a:prstGeom prst="rect">
             <a:avLst/>
@@ -3379,7 +3387,7 @@
         </p:nvSpPr>
         <p:spPr>
           <a:xfrm>
-            <a:off x="438912" y="1691640"/>
+            <a:off x="438912" y="1783080"/>
             <a:ext cx="5532120" cy="73152"/>
           </a:xfrm>
           <a:prstGeom prst="rect">
@@ -3422,7 +3430,7 @@
         </p:nvSpPr>
         <p:spPr>
           <a:xfrm>
-            <a:off x="6172200" y="1691640"/>
+            <a:off x="6172200" y="1783080"/>
             <a:ext cx="5532120" cy="73152"/>
           </a:xfrm>
           <a:prstGeom prst="rect">
@@ -3465,7 +3473,7 @@
         </p:nvSpPr>
         <p:spPr>
           <a:xfrm>
-            <a:off x="658368" y="1901952"/>
+            <a:off x="658368" y="1993392"/>
             <a:ext cx="5120640" cy="365760"/>
           </a:xfrm>
           <a:prstGeom prst="rect">
@@ -3474,12 +3482,14 @@
           <a:noFill/>
         </p:spPr>
         <p:txBody>
-          <a:bodyPr wrap="square"/>
+          <a:bodyPr wrap="square">
+            <a:spAutoFit/>
+          </a:bodyPr>
           <a:lstStyle/>
           <a:p>
             <a:pPr algn="l">
               <a:spcAft>
-                <a:spcPts val="400"/>
+                <a:spcPts val="600"/>
               </a:spcAft>
             </a:pPr>
             <a:r>
@@ -3502,8 +3512,8 @@
         </p:nvSpPr>
         <p:spPr>
           <a:xfrm>
-            <a:off x="658368" y="2331720"/>
-            <a:ext cx="5120640" cy="3291840"/>
+            <a:off x="658368" y="2423160"/>
+            <a:ext cx="5120640" cy="3108960"/>
           </a:xfrm>
           <a:prstGeom prst="rect">
             <a:avLst/>
@@ -3511,80 +3521,18 @@
           <a:noFill/>
         </p:spPr>
         <p:txBody>
-          <a:bodyPr wrap="square"/>
+          <a:bodyPr wrap="square">
+            <a:spAutoFit/>
+          </a:bodyPr>
           <a:lstStyle/>
           <a:p>
             <a:pPr algn="l">
               <a:spcAft>
-                <a:spcPts val="400"/>
+                <a:spcPts val="600"/>
               </a:spcAft>
             </a:pPr>
             <a:r>
-              <a:rPr sz="1400" b="0">
-                <a:solidFill>
-                  <a:srgbClr val="F4F7FB"/>
-                </a:solidFill>
-                <a:latin typeface="Microsoft YaHei"/>
-              </a:rPr>
-              <a:t>stor.object / materialize / transfer / alloc / dealloc / pack / unpack</a:t>
-            </a:r>
-          </a:p>
-          <a:p>
-            <a:pPr algn="l">
-              <a:spcAft>
-                <a:spcPts val="400"/>
-              </a:spcAft>
-            </a:pPr>
-            <a:r>
-              <a:rPr sz="1400" b="0">
-                <a:solidFill>
-                  <a:srgbClr val="F4F7FB"/>
-                </a:solidFill>
-                <a:latin typeface="Microsoft YaHei"/>
-              </a:rPr>
-              <a:t>comp.matmul · elemwise · gated_mlp</a:t>
-            </a:r>
-          </a:p>
-          <a:p>
-            <a:pPr algn="l">
-              <a:spcAft>
-                <a:spcPts val="400"/>
-              </a:spcAft>
-            </a:pPr>
-            <a:r>
-              <a:rPr sz="1400" b="0">
-                <a:solidFill>
-                  <a:srgbClr val="F4F7FB"/>
-                </a:solidFill>
-                <a:latin typeface="Microsoft YaHei"/>
-              </a:rPr>
-              <a:t>comm.copy · stream · barrier</a:t>
-            </a:r>
-          </a:p>
-          <a:p>
-            <a:pPr algn="l">
-              <a:spcAft>
-                <a:spcPts val="400"/>
-              </a:spcAft>
-            </a:pPr>
-            <a:r>
-              <a:rPr sz="1400" b="0">
-                <a:solidFill>
-                  <a:srgbClr val="F4F7FB"/>
-                </a:solidFill>
-                <a:latin typeface="Microsoft YaHei"/>
-              </a:rPr>
-              <a:t>sched.task · concurrent · overlap · pipeline · stage · wait</a:t>
-            </a:r>
-          </a:p>
-          <a:p>
-            <a:pPr algn="l">
-              <a:spcAft>
-                <a:spcPts val="400"/>
-              </a:spcAft>
-            </a:pPr>
-            <a:r>
-              <a:rPr sz="1400" b="0">
+              <a:rPr sz="1600" b="0">
                 <a:solidFill>
                   <a:srgbClr val="F4F7FB"/>
                 </a:solidFill>
@@ -3596,11 +3544,11 @@
           <a:p>
             <a:pPr algn="l">
               <a:spcAft>
-                <a:spcPts val="400"/>
+                <a:spcPts val="600"/>
               </a:spcAft>
             </a:pPr>
             <a:r>
-              <a:rPr sz="1400" b="0">
+              <a:rPr sz="1600" b="0">
                 <a:solidFill>
                   <a:srgbClr val="F4F7FB"/>
                 </a:solidFill>
@@ -3612,11 +3560,11 @@
           <a:p>
             <a:pPr algn="l">
               <a:spcAft>
-                <a:spcPts val="400"/>
+                <a:spcPts val="600"/>
               </a:spcAft>
             </a:pPr>
             <a:r>
-              <a:rPr sz="1400" b="0">
+              <a:rPr sz="1600" b="0">
                 <a:solidFill>
                   <a:srgbClr val="F4F7FB"/>
                 </a:solidFill>
@@ -3628,11 +3576,11 @@
           <a:p>
             <a:pPr algn="l">
               <a:spcAft>
-                <a:spcPts val="400"/>
+                <a:spcPts val="600"/>
               </a:spcAft>
             </a:pPr>
             <a:r>
-              <a:rPr sz="1400" b="0">
+              <a:rPr sz="1600" b="0">
                 <a:solidFill>
                   <a:srgbClr val="F4F7FB"/>
                 </a:solidFill>
@@ -3644,17 +3592,33 @@
           <a:p>
             <a:pPr algn="l">
               <a:spcAft>
-                <a:spcPts val="400"/>
+                <a:spcPts val="600"/>
               </a:spcAft>
             </a:pPr>
             <a:r>
-              <a:rPr sz="1400" b="0">
+              <a:rPr sz="1600" b="0">
                 <a:solidFill>
                   <a:srgbClr val="F4F7FB"/>
                 </a:solidFill>
                 <a:latin typeface="Microsoft YaHei"/>
               </a:rPr>
-              <a:t>baseline 36fd6fd     next_cut = NOT OPENED</a:t>
+              <a:t>baseline 36fd6fd</a:t>
+            </a:r>
+          </a:p>
+          <a:p>
+            <a:pPr algn="l">
+              <a:spcAft>
+                <a:spcPts val="600"/>
+              </a:spcAft>
+            </a:pPr>
+            <a:r>
+              <a:rPr sz="1600" b="0">
+                <a:solidFill>
+                  <a:srgbClr val="F4F7FB"/>
+                </a:solidFill>
+                <a:latin typeface="Microsoft YaHei"/>
+              </a:rPr>
+              <a:t>next_cut = NOT OPENED</a:t>
             </a:r>
           </a:p>
         </p:txBody>
@@ -3667,7 +3631,7 @@
         </p:nvSpPr>
         <p:spPr>
           <a:xfrm>
-            <a:off x="6391656" y="1901952"/>
+            <a:off x="6391656" y="1993392"/>
             <a:ext cx="5120640" cy="365760"/>
           </a:xfrm>
           <a:prstGeom prst="rect">
@@ -3676,12 +3640,14 @@
           <a:noFill/>
         </p:spPr>
         <p:txBody>
-          <a:bodyPr wrap="square"/>
+          <a:bodyPr wrap="square">
+            <a:spAutoFit/>
+          </a:bodyPr>
           <a:lstStyle/>
           <a:p>
             <a:pPr algn="l">
               <a:spcAft>
-                <a:spcPts val="400"/>
+                <a:spcPts val="600"/>
               </a:spcAft>
             </a:pPr>
             <a:r>
@@ -3704,8 +3670,8 @@
         </p:nvSpPr>
         <p:spPr>
           <a:xfrm>
-            <a:off x="6391656" y="2331720"/>
-            <a:ext cx="5120640" cy="3291840"/>
+            <a:off x="6391656" y="2423160"/>
+            <a:ext cx="5120640" cy="3108960"/>
           </a:xfrm>
           <a:prstGeom prst="rect">
             <a:avLst/>
@@ -3713,12 +3679,14 @@
           <a:noFill/>
         </p:spPr>
         <p:txBody>
-          <a:bodyPr wrap="square"/>
+          <a:bodyPr wrap="square">
+            <a:spAutoFit/>
+          </a:bodyPr>
           <a:lstStyle/>
           <a:p>
             <a:pPr algn="l">
               <a:spcAft>
-                <a:spcPts val="400"/>
+                <a:spcPts val="600"/>
               </a:spcAft>
             </a:pPr>
             <a:r>
@@ -3734,7 +3702,7 @@
           <a:p>
             <a:pPr algn="l">
               <a:spcAft>
-                <a:spcPts val="400"/>
+                <a:spcPts val="600"/>
               </a:spcAft>
             </a:pPr>
             <a:r>
@@ -3750,7 +3718,7 @@
           <a:p>
             <a:pPr algn="l">
               <a:spcAft>
-                <a:spcPts val="400"/>
+                <a:spcPts val="600"/>
               </a:spcAft>
             </a:pPr>
             <a:r>
@@ -3766,7 +3734,7 @@
           <a:p>
             <a:pPr algn="l">
               <a:spcAft>
-                <a:spcPts val="400"/>
+                <a:spcPts val="600"/>
               </a:spcAft>
             </a:pPr>
             <a:r>
@@ -3782,7 +3750,7 @@
           <a:p>
             <a:pPr algn="l">
               <a:spcAft>
-                <a:spcPts val="400"/>
+                <a:spcPts val="600"/>
               </a:spcAft>
             </a:pPr>
             <a:r>
@@ -3792,53 +3760,125 @@
                 </a:solidFill>
                 <a:latin typeface="Microsoft YaHei"/>
               </a:rPr>
-              <a:t>这些是研究示意</a:t>
-            </a:r>
-          </a:p>
-          <a:p>
-            <a:pPr algn="l">
-              <a:spcAft>
-                <a:spcPts val="400"/>
-              </a:spcAft>
-            </a:pPr>
-            <a:r>
-              <a:rPr sz="1600" b="0">
-                <a:solidFill>
-                  <a:srgbClr val="F4F7FB"/>
-                </a:solidFill>
-                <a:latin typeface="Microsoft YaHei"/>
-              </a:rPr>
-              <a:t>不是 dialect op，也不是 inhabitant</a:t>
-            </a:r>
-          </a:p>
-          <a:p>
-            <a:pPr algn="l">
-              <a:spcAft>
-                <a:spcPts val="400"/>
-              </a:spcAft>
-            </a:pPr>
-            <a:r>
-              <a:rPr sz="1600" b="0">
-                <a:solidFill>
-                  <a:srgbClr val="F4F7FB"/>
-                </a:solidFill>
-                <a:latin typeface="Microsoft YaHei"/>
-              </a:rPr>
-              <a:t>不据此打开新合同</a:t>
-            </a:r>
-          </a:p>
-        </p:txBody>
-      </p:sp>
-      <p:sp>
-        <p:nvSpPr>
-          <p:cNvPr id="15" name="TextBox 14"/>
+              <a:t>研究示意，不是 dialect op，也不是 inhabitant</a:t>
+            </a:r>
+          </a:p>
+        </p:txBody>
+      </p:sp>
+    </p:spTree>
+  </p:cSld>
+  <p:clrMapOvr>
+    <a:masterClrMapping/>
+  </p:clrMapOvr>
+</p:sld>
+</file>
+
+<file path=ppt/slides/slide2.xml><?xml version="1.0" encoding="utf-8"?>
+<p:sld xmlns:a="http://schemas.openxmlformats.org/drawingml/2006/main" xmlns:p="http://schemas.openxmlformats.org/presentationml/2006/main" xmlns:r="http://schemas.openxmlformats.org/officeDocument/2006/relationships">
+  <p:cSld>
+    <p:spTree>
+      <p:nvGrpSpPr>
+        <p:cNvPr id="1" name=""/>
+        <p:cNvGrpSpPr/>
+        <p:nvPr/>
+      </p:nvGrpSpPr>
+      <p:grpSpPr/>
+      <p:sp>
+        <p:nvSpPr>
+          <p:cNvPr id="2" name="Rectangle 1"/>
+          <p:cNvSpPr/>
+          <p:nvPr/>
+        </p:nvSpPr>
+        <p:spPr>
+          <a:xfrm>
+            <a:off x="0" y="0"/>
+            <a:ext cx="12191695" cy="6858000"/>
+          </a:xfrm>
+          <a:prstGeom prst="rect">
+            <a:avLst/>
+          </a:prstGeom>
+          <a:solidFill>
+            <a:srgbClr val="0B1220"/>
+          </a:solidFill>
+          <a:ln>
+            <a:noFill/>
+          </a:ln>
+        </p:spPr>
+        <p:style>
+          <a:lnRef idx="1">
+            <a:schemeClr val="accent1"/>
+          </a:lnRef>
+          <a:fillRef idx="3">
+            <a:schemeClr val="accent1"/>
+          </a:fillRef>
+          <a:effectRef idx="2">
+            <a:schemeClr val="accent1"/>
+          </a:effectRef>
+          <a:fontRef idx="minor">
+            <a:schemeClr val="lt1"/>
+          </a:fontRef>
+        </p:style>
+        <p:txBody>
+          <a:bodyPr rtlCol="0" anchor="ctr"/>
+          <a:lstStyle/>
+          <a:p>
+            <a:pPr algn="ctr"/>
+          </a:p>
+        </p:txBody>
+      </p:sp>
+      <p:sp>
+        <p:nvSpPr>
+          <p:cNvPr id="3" name="Rectangle 2"/>
+          <p:cNvSpPr/>
+          <p:nvPr/>
+        </p:nvSpPr>
+        <p:spPr>
+          <a:xfrm>
+            <a:off x="0" y="0"/>
+            <a:ext cx="109728" cy="6858000"/>
+          </a:xfrm>
+          <a:prstGeom prst="rect">
+            <a:avLst/>
+          </a:prstGeom>
+          <a:solidFill>
+            <a:srgbClr val="7EB6FF"/>
+          </a:solidFill>
+          <a:ln>
+            <a:noFill/>
+          </a:ln>
+        </p:spPr>
+        <p:style>
+          <a:lnRef idx="1">
+            <a:schemeClr val="accent1"/>
+          </a:lnRef>
+          <a:fillRef idx="3">
+            <a:schemeClr val="accent1"/>
+          </a:fillRef>
+          <a:effectRef idx="2">
+            <a:schemeClr val="accent1"/>
+          </a:effectRef>
+          <a:fontRef idx="minor">
+            <a:schemeClr val="lt1"/>
+          </a:fontRef>
+        </p:style>
+        <p:txBody>
+          <a:bodyPr rtlCol="0" anchor="ctr"/>
+          <a:lstStyle/>
+          <a:p>
+            <a:pPr algn="ctr"/>
+          </a:p>
+        </p:txBody>
+      </p:sp>
+      <p:sp>
+        <p:nvSpPr>
+          <p:cNvPr id="4" name="TextBox 3"/>
           <p:cNvSpPr txBox="1"/>
           <p:nvPr/>
         </p:nvSpPr>
         <p:spPr>
           <a:xfrm>
-            <a:off x="438912" y="6035040"/>
-            <a:ext cx="11155680" cy="502920"/>
+            <a:off x="438912" y="256032"/>
+            <a:ext cx="11155680" cy="292608"/>
           </a:xfrm>
           <a:prstGeom prst="rect">
             <a:avLst/>
@@ -3846,22 +3886,1265 @@
           <a:noFill/>
         </p:spPr>
         <p:txBody>
-          <a:bodyPr wrap="square"/>
+          <a:bodyPr wrap="square">
+            <a:spAutoFit/>
+          </a:bodyPr>
           <a:lstStyle/>
           <a:p>
             <a:pPr algn="l">
               <a:spcAft>
-                <a:spcPts val="400"/>
+                <a:spcPts val="600"/>
               </a:spcAft>
             </a:pPr>
             <a:r>
-              <a:rPr sz="1300" b="0">
-                <a:solidFill>
-                  <a:srgbClr val="8B98AB"/>
+              <a:rPr sz="1400" b="1">
+                <a:solidFill>
+                  <a:srgbClr val="7EB6FF"/>
                 </a:solidFill>
                 <a:latin typeface="Microsoft YaHei"/>
               </a:rPr>
-              <a:t>语义基线不因本页改变。对照页：docs/design/goal-alignment-v1.md</a:t>
+              <a:t>现状  2 / 3    仓库里的 op</a:t>
+            </a:r>
+          </a:p>
+        </p:txBody>
+      </p:sp>
+      <p:sp>
+        <p:nvSpPr>
+          <p:cNvPr id="5" name="TextBox 4"/>
+          <p:cNvSpPr txBox="1"/>
+          <p:nvPr/>
+        </p:nvSpPr>
+        <p:spPr>
+          <a:xfrm>
+            <a:off x="438912" y="566928"/>
+            <a:ext cx="11155680" cy="502920"/>
+          </a:xfrm>
+          <a:prstGeom prst="rect">
+            <a:avLst/>
+          </a:prstGeom>
+          <a:noFill/>
+        </p:spPr>
+        <p:txBody>
+          <a:bodyPr wrap="square">
+            <a:spAutoFit/>
+          </a:bodyPr>
+          <a:lstStyle/>
+          <a:p>
+            <a:pPr algn="l">
+              <a:spcAft>
+                <a:spcPts val="600"/>
+              </a:spcAft>
+            </a:pPr>
+            <a:r>
+              <a:rPr sz="2600" b="1">
+                <a:solidFill>
+                  <a:srgbClr val="F4F7FB"/>
+                </a:solidFill>
+                <a:latin typeface="Microsoft YaHei"/>
+              </a:rPr>
+              <a:t>汇报草图里的名字，多数还不是 dialect op</a:t>
+            </a:r>
+          </a:p>
+        </p:txBody>
+      </p:sp>
+      <p:sp>
+        <p:nvSpPr>
+          <p:cNvPr id="6" name="Rectangle 5"/>
+          <p:cNvSpPr/>
+          <p:nvPr/>
+        </p:nvSpPr>
+        <p:spPr>
+          <a:xfrm>
+            <a:off x="438912" y="1371600"/>
+            <a:ext cx="11247120" cy="932688"/>
+          </a:xfrm>
+          <a:prstGeom prst="rect">
+            <a:avLst/>
+          </a:prstGeom>
+          <a:solidFill>
+            <a:srgbClr val="152033"/>
+          </a:solidFill>
+          <a:ln>
+            <a:noFill/>
+          </a:ln>
+        </p:spPr>
+        <p:style>
+          <a:lnRef idx="1">
+            <a:schemeClr val="accent1"/>
+          </a:lnRef>
+          <a:fillRef idx="3">
+            <a:schemeClr val="accent1"/>
+          </a:fillRef>
+          <a:effectRef idx="2">
+            <a:schemeClr val="accent1"/>
+          </a:effectRef>
+          <a:fontRef idx="minor">
+            <a:schemeClr val="lt1"/>
+          </a:fontRef>
+        </p:style>
+        <p:txBody>
+          <a:bodyPr rtlCol="0" anchor="ctr"/>
+          <a:lstStyle/>
+          <a:p>
+            <a:pPr algn="ctr"/>
+          </a:p>
+        </p:txBody>
+      </p:sp>
+      <p:sp>
+        <p:nvSpPr>
+          <p:cNvPr id="7" name="TextBox 6"/>
+          <p:cNvSpPr txBox="1"/>
+          <p:nvPr/>
+        </p:nvSpPr>
+        <p:spPr>
+          <a:xfrm>
+            <a:off x="640080" y="1499616"/>
+            <a:ext cx="1828800" cy="640080"/>
+          </a:xfrm>
+          <a:prstGeom prst="rect">
+            <a:avLst/>
+          </a:prstGeom>
+          <a:noFill/>
+        </p:spPr>
+        <p:txBody>
+          <a:bodyPr wrap="square">
+            <a:spAutoFit/>
+          </a:bodyPr>
+          <a:lstStyle/>
+          <a:p>
+            <a:pPr algn="l">
+              <a:spcAft>
+                <a:spcPts val="600"/>
+              </a:spcAft>
+            </a:pPr>
+            <a:r>
+              <a:rPr sz="2000" b="1">
+                <a:solidFill>
+                  <a:srgbClr val="7EB6FF"/>
+                </a:solidFill>
+                <a:latin typeface="Microsoft YaHei"/>
+              </a:rPr>
+              <a:t>stor</a:t>
+            </a:r>
+          </a:p>
+        </p:txBody>
+      </p:sp>
+      <p:sp>
+        <p:nvSpPr>
+          <p:cNvPr id="8" name="TextBox 7"/>
+          <p:cNvSpPr txBox="1"/>
+          <p:nvPr/>
+        </p:nvSpPr>
+        <p:spPr>
+          <a:xfrm>
+            <a:off x="2560320" y="1572768"/>
+            <a:ext cx="8778240" cy="548640"/>
+          </a:xfrm>
+          <a:prstGeom prst="rect">
+            <a:avLst/>
+          </a:prstGeom>
+          <a:noFill/>
+        </p:spPr>
+        <p:txBody>
+          <a:bodyPr wrap="square">
+            <a:spAutoFit/>
+          </a:bodyPr>
+          <a:lstStyle/>
+          <a:p>
+            <a:pPr algn="l">
+              <a:spcAft>
+                <a:spcPts val="600"/>
+              </a:spcAft>
+            </a:pPr>
+            <a:r>
+              <a:rPr sz="1800" b="0">
+                <a:solidFill>
+                  <a:srgbClr val="F4F7FB"/>
+                </a:solidFill>
+                <a:latin typeface="Microsoft YaHei"/>
+              </a:rPr>
+              <a:t>object · materialize · transfer · alloc · dealloc · pack · unpack</a:t>
+            </a:r>
+          </a:p>
+        </p:txBody>
+      </p:sp>
+      <p:sp>
+        <p:nvSpPr>
+          <p:cNvPr id="9" name="Rectangle 8"/>
+          <p:cNvSpPr/>
+          <p:nvPr/>
+        </p:nvSpPr>
+        <p:spPr>
+          <a:xfrm>
+            <a:off x="438912" y="2423160"/>
+            <a:ext cx="11247120" cy="932688"/>
+          </a:xfrm>
+          <a:prstGeom prst="rect">
+            <a:avLst/>
+          </a:prstGeom>
+          <a:solidFill>
+            <a:srgbClr val="152033"/>
+          </a:solidFill>
+          <a:ln>
+            <a:noFill/>
+          </a:ln>
+        </p:spPr>
+        <p:style>
+          <a:lnRef idx="1">
+            <a:schemeClr val="accent1"/>
+          </a:lnRef>
+          <a:fillRef idx="3">
+            <a:schemeClr val="accent1"/>
+          </a:fillRef>
+          <a:effectRef idx="2">
+            <a:schemeClr val="accent1"/>
+          </a:effectRef>
+          <a:fontRef idx="minor">
+            <a:schemeClr val="lt1"/>
+          </a:fontRef>
+        </p:style>
+        <p:txBody>
+          <a:bodyPr rtlCol="0" anchor="ctr"/>
+          <a:lstStyle/>
+          <a:p>
+            <a:pPr algn="ctr"/>
+          </a:p>
+        </p:txBody>
+      </p:sp>
+      <p:sp>
+        <p:nvSpPr>
+          <p:cNvPr id="10" name="TextBox 9"/>
+          <p:cNvSpPr txBox="1"/>
+          <p:nvPr/>
+        </p:nvSpPr>
+        <p:spPr>
+          <a:xfrm>
+            <a:off x="640080" y="2551176"/>
+            <a:ext cx="1828800" cy="640080"/>
+          </a:xfrm>
+          <a:prstGeom prst="rect">
+            <a:avLst/>
+          </a:prstGeom>
+          <a:noFill/>
+        </p:spPr>
+        <p:txBody>
+          <a:bodyPr wrap="square">
+            <a:spAutoFit/>
+          </a:bodyPr>
+          <a:lstStyle/>
+          <a:p>
+            <a:pPr algn="l">
+              <a:spcAft>
+                <a:spcPts val="600"/>
+              </a:spcAft>
+            </a:pPr>
+            <a:r>
+              <a:rPr sz="2000" b="1">
+                <a:solidFill>
+                  <a:srgbClr val="7EB6FF"/>
+                </a:solidFill>
+                <a:latin typeface="Microsoft YaHei"/>
+              </a:rPr>
+              <a:t>comp</a:t>
+            </a:r>
+          </a:p>
+        </p:txBody>
+      </p:sp>
+      <p:sp>
+        <p:nvSpPr>
+          <p:cNvPr id="11" name="TextBox 10"/>
+          <p:cNvSpPr txBox="1"/>
+          <p:nvPr/>
+        </p:nvSpPr>
+        <p:spPr>
+          <a:xfrm>
+            <a:off x="2560320" y="2624328"/>
+            <a:ext cx="8778240" cy="548640"/>
+          </a:xfrm>
+          <a:prstGeom prst="rect">
+            <a:avLst/>
+          </a:prstGeom>
+          <a:noFill/>
+        </p:spPr>
+        <p:txBody>
+          <a:bodyPr wrap="square">
+            <a:spAutoFit/>
+          </a:bodyPr>
+          <a:lstStyle/>
+          <a:p>
+            <a:pPr algn="l">
+              <a:spcAft>
+                <a:spcPts val="600"/>
+              </a:spcAft>
+            </a:pPr>
+            <a:r>
+              <a:rPr sz="1800" b="0">
+                <a:solidFill>
+                  <a:srgbClr val="F4F7FB"/>
+                </a:solidFill>
+                <a:latin typeface="Microsoft YaHei"/>
+              </a:rPr>
+              <a:t>matmul · elemwise · gated_mlp</a:t>
+            </a:r>
+          </a:p>
+        </p:txBody>
+      </p:sp>
+      <p:sp>
+        <p:nvSpPr>
+          <p:cNvPr id="12" name="Rectangle 11"/>
+          <p:cNvSpPr/>
+          <p:nvPr/>
+        </p:nvSpPr>
+        <p:spPr>
+          <a:xfrm>
+            <a:off x="438912" y="3474720"/>
+            <a:ext cx="11247120" cy="932688"/>
+          </a:xfrm>
+          <a:prstGeom prst="rect">
+            <a:avLst/>
+          </a:prstGeom>
+          <a:solidFill>
+            <a:srgbClr val="152033"/>
+          </a:solidFill>
+          <a:ln>
+            <a:noFill/>
+          </a:ln>
+        </p:spPr>
+        <p:style>
+          <a:lnRef idx="1">
+            <a:schemeClr val="accent1"/>
+          </a:lnRef>
+          <a:fillRef idx="3">
+            <a:schemeClr val="accent1"/>
+          </a:fillRef>
+          <a:effectRef idx="2">
+            <a:schemeClr val="accent1"/>
+          </a:effectRef>
+          <a:fontRef idx="minor">
+            <a:schemeClr val="lt1"/>
+          </a:fontRef>
+        </p:style>
+        <p:txBody>
+          <a:bodyPr rtlCol="0" anchor="ctr"/>
+          <a:lstStyle/>
+          <a:p>
+            <a:pPr algn="ctr"/>
+          </a:p>
+        </p:txBody>
+      </p:sp>
+      <p:sp>
+        <p:nvSpPr>
+          <p:cNvPr id="13" name="TextBox 12"/>
+          <p:cNvSpPr txBox="1"/>
+          <p:nvPr/>
+        </p:nvSpPr>
+        <p:spPr>
+          <a:xfrm>
+            <a:off x="640080" y="3602736"/>
+            <a:ext cx="1828800" cy="640080"/>
+          </a:xfrm>
+          <a:prstGeom prst="rect">
+            <a:avLst/>
+          </a:prstGeom>
+          <a:noFill/>
+        </p:spPr>
+        <p:txBody>
+          <a:bodyPr wrap="square">
+            <a:spAutoFit/>
+          </a:bodyPr>
+          <a:lstStyle/>
+          <a:p>
+            <a:pPr algn="l">
+              <a:spcAft>
+                <a:spcPts val="600"/>
+              </a:spcAft>
+            </a:pPr>
+            <a:r>
+              <a:rPr sz="2000" b="1">
+                <a:solidFill>
+                  <a:srgbClr val="7EB6FF"/>
+                </a:solidFill>
+                <a:latin typeface="Microsoft YaHei"/>
+              </a:rPr>
+              <a:t>comm</a:t>
+            </a:r>
+          </a:p>
+        </p:txBody>
+      </p:sp>
+      <p:sp>
+        <p:nvSpPr>
+          <p:cNvPr id="14" name="TextBox 13"/>
+          <p:cNvSpPr txBox="1"/>
+          <p:nvPr/>
+        </p:nvSpPr>
+        <p:spPr>
+          <a:xfrm>
+            <a:off x="2560320" y="3675888"/>
+            <a:ext cx="8778240" cy="548640"/>
+          </a:xfrm>
+          <a:prstGeom prst="rect">
+            <a:avLst/>
+          </a:prstGeom>
+          <a:noFill/>
+        </p:spPr>
+        <p:txBody>
+          <a:bodyPr wrap="square">
+            <a:spAutoFit/>
+          </a:bodyPr>
+          <a:lstStyle/>
+          <a:p>
+            <a:pPr algn="l">
+              <a:spcAft>
+                <a:spcPts val="600"/>
+              </a:spcAft>
+            </a:pPr>
+            <a:r>
+              <a:rPr sz="1800" b="0">
+                <a:solidFill>
+                  <a:srgbClr val="F4F7FB"/>
+                </a:solidFill>
+                <a:latin typeface="Microsoft YaHei"/>
+              </a:rPr>
+              <a:t>comm.copy · stream · barrier     kind: p2p · broadcast · reduce</a:t>
+            </a:r>
+          </a:p>
+        </p:txBody>
+      </p:sp>
+      <p:sp>
+        <p:nvSpPr>
+          <p:cNvPr id="15" name="Rectangle 14"/>
+          <p:cNvSpPr/>
+          <p:nvPr/>
+        </p:nvSpPr>
+        <p:spPr>
+          <a:xfrm>
+            <a:off x="438912" y="4526279"/>
+            <a:ext cx="11247120" cy="932688"/>
+          </a:xfrm>
+          <a:prstGeom prst="rect">
+            <a:avLst/>
+          </a:prstGeom>
+          <a:solidFill>
+            <a:srgbClr val="152033"/>
+          </a:solidFill>
+          <a:ln>
+            <a:noFill/>
+          </a:ln>
+        </p:spPr>
+        <p:style>
+          <a:lnRef idx="1">
+            <a:schemeClr val="accent1"/>
+          </a:lnRef>
+          <a:fillRef idx="3">
+            <a:schemeClr val="accent1"/>
+          </a:fillRef>
+          <a:effectRef idx="2">
+            <a:schemeClr val="accent1"/>
+          </a:effectRef>
+          <a:fontRef idx="minor">
+            <a:schemeClr val="lt1"/>
+          </a:fontRef>
+        </p:style>
+        <p:txBody>
+          <a:bodyPr rtlCol="0" anchor="ctr"/>
+          <a:lstStyle/>
+          <a:p>
+            <a:pPr algn="ctr"/>
+          </a:p>
+        </p:txBody>
+      </p:sp>
+      <p:sp>
+        <p:nvSpPr>
+          <p:cNvPr id="16" name="TextBox 15"/>
+          <p:cNvSpPr txBox="1"/>
+          <p:nvPr/>
+        </p:nvSpPr>
+        <p:spPr>
+          <a:xfrm>
+            <a:off x="640080" y="4654295"/>
+            <a:ext cx="1828800" cy="640080"/>
+          </a:xfrm>
+          <a:prstGeom prst="rect">
+            <a:avLst/>
+          </a:prstGeom>
+          <a:noFill/>
+        </p:spPr>
+        <p:txBody>
+          <a:bodyPr wrap="square">
+            <a:spAutoFit/>
+          </a:bodyPr>
+          <a:lstStyle/>
+          <a:p>
+            <a:pPr algn="l">
+              <a:spcAft>
+                <a:spcPts val="600"/>
+              </a:spcAft>
+            </a:pPr>
+            <a:r>
+              <a:rPr sz="2000" b="1">
+                <a:solidFill>
+                  <a:srgbClr val="7EB6FF"/>
+                </a:solidFill>
+                <a:latin typeface="Microsoft YaHei"/>
+              </a:rPr>
+              <a:t>sched</a:t>
+            </a:r>
+          </a:p>
+        </p:txBody>
+      </p:sp>
+      <p:sp>
+        <p:nvSpPr>
+          <p:cNvPr id="17" name="TextBox 16"/>
+          <p:cNvSpPr txBox="1"/>
+          <p:nvPr/>
+        </p:nvSpPr>
+        <p:spPr>
+          <a:xfrm>
+            <a:off x="2560320" y="4727447"/>
+            <a:ext cx="8778240" cy="548640"/>
+          </a:xfrm>
+          <a:prstGeom prst="rect">
+            <a:avLst/>
+          </a:prstGeom>
+          <a:noFill/>
+        </p:spPr>
+        <p:txBody>
+          <a:bodyPr wrap="square">
+            <a:spAutoFit/>
+          </a:bodyPr>
+          <a:lstStyle/>
+          <a:p>
+            <a:pPr algn="l">
+              <a:spcAft>
+                <a:spcPts val="600"/>
+              </a:spcAft>
+            </a:pPr>
+            <a:r>
+              <a:rPr sz="1800" b="0">
+                <a:solidFill>
+                  <a:srgbClr val="F4F7FB"/>
+                </a:solidFill>
+                <a:latin typeface="Microsoft YaHei"/>
+              </a:rPr>
+              <a:t>task · concurrent · overlap · sched.pipeline · stage · wait</a:t>
+            </a:r>
+          </a:p>
+        </p:txBody>
+      </p:sp>
+      <p:sp>
+        <p:nvSpPr>
+          <p:cNvPr id="18" name="TextBox 17"/>
+          <p:cNvSpPr txBox="1"/>
+          <p:nvPr/>
+        </p:nvSpPr>
+        <p:spPr>
+          <a:xfrm>
+            <a:off x="438912" y="5669280"/>
+            <a:ext cx="11155680" cy="822960"/>
+          </a:xfrm>
+          <a:prstGeom prst="rect">
+            <a:avLst/>
+          </a:prstGeom>
+          <a:noFill/>
+        </p:spPr>
+        <p:txBody>
+          <a:bodyPr wrap="square">
+            <a:spAutoFit/>
+          </a:bodyPr>
+          <a:lstStyle/>
+          <a:p>
+            <a:pPr algn="l">
+              <a:spcAft>
+                <a:spcPts val="600"/>
+              </a:spcAft>
+            </a:pPr>
+            <a:r>
+              <a:rPr sz="1500" b="0">
+                <a:solidFill>
+                  <a:srgbClr val="A8B3C7"/>
+                </a:solidFill>
+                <a:latin typeface="Microsoft YaHei"/>
+              </a:rPr>
+              <a:t>空间：register · sram · dram · hbm · ssd · cim · host</a:t>
+            </a:r>
+          </a:p>
+          <a:p>
+            <a:pPr algn="l">
+              <a:spcAft>
+                <a:spcPts val="600"/>
+              </a:spcAft>
+            </a:pPr>
+            <a:r>
+              <a:rPr sz="1500" b="0">
+                <a:solidFill>
+                  <a:srgbClr val="A8B3C7"/>
+                </a:solidFill>
+                <a:latin typeface="Microsoft YaHei"/>
+              </a:rPr>
+              <a:t>没有 comm.dispatch、comp.attention、sched.hb。HB 是 schedule 关系，不是一个 op。</a:t>
+            </a:r>
+          </a:p>
+        </p:txBody>
+      </p:sp>
+    </p:spTree>
+  </p:cSld>
+  <p:clrMapOvr>
+    <a:masterClrMapping/>
+  </p:clrMapOvr>
+</p:sld>
+</file>
+
+<file path=ppt/slides/slide3.xml><?xml version="1.0" encoding="utf-8"?>
+<p:sld xmlns:a="http://schemas.openxmlformats.org/drawingml/2006/main" xmlns:p="http://schemas.openxmlformats.org/presentationml/2006/main" xmlns:r="http://schemas.openxmlformats.org/officeDocument/2006/relationships">
+  <p:cSld>
+    <p:spTree>
+      <p:nvGrpSpPr>
+        <p:cNvPr id="1" name=""/>
+        <p:cNvGrpSpPr/>
+        <p:nvPr/>
+      </p:nvGrpSpPr>
+      <p:grpSpPr/>
+      <p:sp>
+        <p:nvSpPr>
+          <p:cNvPr id="2" name="Rectangle 1"/>
+          <p:cNvSpPr/>
+          <p:nvPr/>
+        </p:nvSpPr>
+        <p:spPr>
+          <a:xfrm>
+            <a:off x="0" y="0"/>
+            <a:ext cx="12191695" cy="6858000"/>
+          </a:xfrm>
+          <a:prstGeom prst="rect">
+            <a:avLst/>
+          </a:prstGeom>
+          <a:solidFill>
+            <a:srgbClr val="0B1220"/>
+          </a:solidFill>
+          <a:ln>
+            <a:noFill/>
+          </a:ln>
+        </p:spPr>
+        <p:style>
+          <a:lnRef idx="1">
+            <a:schemeClr val="accent1"/>
+          </a:lnRef>
+          <a:fillRef idx="3">
+            <a:schemeClr val="accent1"/>
+          </a:fillRef>
+          <a:effectRef idx="2">
+            <a:schemeClr val="accent1"/>
+          </a:effectRef>
+          <a:fontRef idx="minor">
+            <a:schemeClr val="lt1"/>
+          </a:fontRef>
+        </p:style>
+        <p:txBody>
+          <a:bodyPr rtlCol="0" anchor="ctr"/>
+          <a:lstStyle/>
+          <a:p>
+            <a:pPr algn="ctr"/>
+          </a:p>
+        </p:txBody>
+      </p:sp>
+      <p:sp>
+        <p:nvSpPr>
+          <p:cNvPr id="3" name="Rectangle 2"/>
+          <p:cNvSpPr/>
+          <p:nvPr/>
+        </p:nvSpPr>
+        <p:spPr>
+          <a:xfrm>
+            <a:off x="0" y="0"/>
+            <a:ext cx="109728" cy="6858000"/>
+          </a:xfrm>
+          <a:prstGeom prst="rect">
+            <a:avLst/>
+          </a:prstGeom>
+          <a:solidFill>
+            <a:srgbClr val="7EB6FF"/>
+          </a:solidFill>
+          <a:ln>
+            <a:noFill/>
+          </a:ln>
+        </p:spPr>
+        <p:style>
+          <a:lnRef idx="1">
+            <a:schemeClr val="accent1"/>
+          </a:lnRef>
+          <a:fillRef idx="3">
+            <a:schemeClr val="accent1"/>
+          </a:fillRef>
+          <a:effectRef idx="2">
+            <a:schemeClr val="accent1"/>
+          </a:effectRef>
+          <a:fontRef idx="minor">
+            <a:schemeClr val="lt1"/>
+          </a:fontRef>
+        </p:style>
+        <p:txBody>
+          <a:bodyPr rtlCol="0" anchor="ctr"/>
+          <a:lstStyle/>
+          <a:p>
+            <a:pPr algn="ctr"/>
+          </a:p>
+        </p:txBody>
+      </p:sp>
+      <p:sp>
+        <p:nvSpPr>
+          <p:cNvPr id="4" name="TextBox 3"/>
+          <p:cNvSpPr txBox="1"/>
+          <p:nvPr/>
+        </p:nvSpPr>
+        <p:spPr>
+          <a:xfrm>
+            <a:off x="438912" y="256032"/>
+            <a:ext cx="11155680" cy="292608"/>
+          </a:xfrm>
+          <a:prstGeom prst="rect">
+            <a:avLst/>
+          </a:prstGeom>
+          <a:noFill/>
+        </p:spPr>
+        <p:txBody>
+          <a:bodyPr wrap="square">
+            <a:spAutoFit/>
+          </a:bodyPr>
+          <a:lstStyle/>
+          <a:p>
+            <a:pPr algn="l">
+              <a:spcAft>
+                <a:spcPts val="600"/>
+              </a:spcAft>
+            </a:pPr>
+            <a:r>
+              <a:rPr sz="1400" b="1">
+                <a:solidFill>
+                  <a:srgbClr val="7EB6FF"/>
+                </a:solidFill>
+                <a:latin typeface="Microsoft YaHei"/>
+              </a:rPr>
+              <a:t>现状  3 / 3    下一刀何时才开</a:t>
+            </a:r>
+          </a:p>
+        </p:txBody>
+      </p:sp>
+      <p:sp>
+        <p:nvSpPr>
+          <p:cNvPr id="5" name="TextBox 4"/>
+          <p:cNvSpPr txBox="1"/>
+          <p:nvPr/>
+        </p:nvSpPr>
+        <p:spPr>
+          <a:xfrm>
+            <a:off x="438912" y="566928"/>
+            <a:ext cx="11155680" cy="502920"/>
+          </a:xfrm>
+          <a:prstGeom prst="rect">
+            <a:avLst/>
+          </a:prstGeom>
+          <a:noFill/>
+        </p:spPr>
+        <p:txBody>
+          <a:bodyPr wrap="square">
+            <a:spAutoFit/>
+          </a:bodyPr>
+          <a:lstStyle/>
+          <a:p>
+            <a:pPr algn="l">
+              <a:spcAft>
+                <a:spcPts val="600"/>
+              </a:spcAft>
+            </a:pPr>
+            <a:r>
+              <a:rPr sz="2400" b="1">
+                <a:solidFill>
+                  <a:srgbClr val="F4F7FB"/>
+                </a:solidFill>
+                <a:latin typeface="Microsoft YaHei"/>
+              </a:rPr>
+              <a:t>四个 dialect 仍表达不了必要关系，才提议新合同</a:t>
+            </a:r>
+          </a:p>
+        </p:txBody>
+      </p:sp>
+      <p:sp>
+        <p:nvSpPr>
+          <p:cNvPr id="6" name="Rectangle 5"/>
+          <p:cNvSpPr/>
+          <p:nvPr/>
+        </p:nvSpPr>
+        <p:spPr>
+          <a:xfrm>
+            <a:off x="438912" y="1325880"/>
+            <a:ext cx="6858000" cy="4160520"/>
+          </a:xfrm>
+          <a:prstGeom prst="rect">
+            <a:avLst/>
+          </a:prstGeom>
+          <a:solidFill>
+            <a:srgbClr val="152033"/>
+          </a:solidFill>
+          <a:ln>
+            <a:noFill/>
+          </a:ln>
+        </p:spPr>
+        <p:style>
+          <a:lnRef idx="1">
+            <a:schemeClr val="accent1"/>
+          </a:lnRef>
+          <a:fillRef idx="3">
+            <a:schemeClr val="accent1"/>
+          </a:fillRef>
+          <a:effectRef idx="2">
+            <a:schemeClr val="accent1"/>
+          </a:effectRef>
+          <a:fontRef idx="minor">
+            <a:schemeClr val="lt1"/>
+          </a:fontRef>
+        </p:style>
+        <p:txBody>
+          <a:bodyPr rtlCol="0" anchor="ctr"/>
+          <a:lstStyle/>
+          <a:p>
+            <a:pPr algn="ctr"/>
+          </a:p>
+        </p:txBody>
+      </p:sp>
+      <p:sp>
+        <p:nvSpPr>
+          <p:cNvPr id="7" name="Rectangle 6"/>
+          <p:cNvSpPr/>
+          <p:nvPr/>
+        </p:nvSpPr>
+        <p:spPr>
+          <a:xfrm>
+            <a:off x="7452360" y="1325880"/>
+            <a:ext cx="4297680" cy="4160520"/>
+          </a:xfrm>
+          <a:prstGeom prst="rect">
+            <a:avLst/>
+          </a:prstGeom>
+          <a:solidFill>
+            <a:srgbClr val="152033"/>
+          </a:solidFill>
+          <a:ln>
+            <a:noFill/>
+          </a:ln>
+        </p:spPr>
+        <p:style>
+          <a:lnRef idx="1">
+            <a:schemeClr val="accent1"/>
+          </a:lnRef>
+          <a:fillRef idx="3">
+            <a:schemeClr val="accent1"/>
+          </a:fillRef>
+          <a:effectRef idx="2">
+            <a:schemeClr val="accent1"/>
+          </a:effectRef>
+          <a:fontRef idx="minor">
+            <a:schemeClr val="lt1"/>
+          </a:fontRef>
+        </p:style>
+        <p:txBody>
+          <a:bodyPr rtlCol="0" anchor="ctr"/>
+          <a:lstStyle/>
+          <a:p>
+            <a:pPr algn="ctr"/>
+          </a:p>
+        </p:txBody>
+      </p:sp>
+      <p:sp>
+        <p:nvSpPr>
+          <p:cNvPr id="8" name="Rectangle 7"/>
+          <p:cNvSpPr/>
+          <p:nvPr/>
+        </p:nvSpPr>
+        <p:spPr>
+          <a:xfrm>
+            <a:off x="438912" y="1325880"/>
+            <a:ext cx="6858000" cy="73152"/>
+          </a:xfrm>
+          <a:prstGeom prst="rect">
+            <a:avLst/>
+          </a:prstGeom>
+          <a:solidFill>
+            <a:srgbClr val="7EB6FF"/>
+          </a:solidFill>
+          <a:ln>
+            <a:noFill/>
+          </a:ln>
+        </p:spPr>
+        <p:style>
+          <a:lnRef idx="1">
+            <a:schemeClr val="accent1"/>
+          </a:lnRef>
+          <a:fillRef idx="3">
+            <a:schemeClr val="accent1"/>
+          </a:fillRef>
+          <a:effectRef idx="2">
+            <a:schemeClr val="accent1"/>
+          </a:effectRef>
+          <a:fontRef idx="minor">
+            <a:schemeClr val="lt1"/>
+          </a:fontRef>
+        </p:style>
+        <p:txBody>
+          <a:bodyPr rtlCol="0" anchor="ctr"/>
+          <a:lstStyle/>
+          <a:p>
+            <a:pPr algn="ctr"/>
+          </a:p>
+        </p:txBody>
+      </p:sp>
+      <p:sp>
+        <p:nvSpPr>
+          <p:cNvPr id="9" name="Rectangle 8"/>
+          <p:cNvSpPr/>
+          <p:nvPr/>
+        </p:nvSpPr>
+        <p:spPr>
+          <a:xfrm>
+            <a:off x="7452360" y="1325880"/>
+            <a:ext cx="4297680" cy="73152"/>
+          </a:xfrm>
+          <a:prstGeom prst="rect">
+            <a:avLst/>
+          </a:prstGeom>
+          <a:solidFill>
+            <a:srgbClr val="E7C27A"/>
+          </a:solidFill>
+          <a:ln>
+            <a:noFill/>
+          </a:ln>
+        </p:spPr>
+        <p:style>
+          <a:lnRef idx="1">
+            <a:schemeClr val="accent1"/>
+          </a:lnRef>
+          <a:fillRef idx="3">
+            <a:schemeClr val="accent1"/>
+          </a:fillRef>
+          <a:effectRef idx="2">
+            <a:schemeClr val="accent1"/>
+          </a:effectRef>
+          <a:fontRef idx="minor">
+            <a:schemeClr val="lt1"/>
+          </a:fontRef>
+        </p:style>
+        <p:txBody>
+          <a:bodyPr rtlCol="0" anchor="ctr"/>
+          <a:lstStyle/>
+          <a:p>
+            <a:pPr algn="ctr"/>
+          </a:p>
+        </p:txBody>
+      </p:sp>
+      <p:sp>
+        <p:nvSpPr>
+          <p:cNvPr id="10" name="TextBox 9"/>
+          <p:cNvSpPr txBox="1"/>
+          <p:nvPr/>
+        </p:nvSpPr>
+        <p:spPr>
+          <a:xfrm>
+            <a:off x="640080" y="1536192"/>
+            <a:ext cx="6492240" cy="3749039"/>
+          </a:xfrm>
+          <a:prstGeom prst="rect">
+            <a:avLst/>
+          </a:prstGeom>
+          <a:noFill/>
+        </p:spPr>
+        <p:txBody>
+          <a:bodyPr wrap="square">
+            <a:spAutoFit/>
+          </a:bodyPr>
+          <a:lstStyle/>
+          <a:p>
+            <a:pPr algn="l">
+              <a:spcAft>
+                <a:spcPts val="600"/>
+              </a:spcAft>
+            </a:pPr>
+            <a:r>
+              <a:rPr sz="1600" b="1">
+                <a:solidFill>
+                  <a:srgbClr val="7EB6FF"/>
+                </a:solidFill>
+                <a:latin typeface="Microsoft YaHei"/>
+              </a:rPr>
+              <a:t>开下一刀，要这四步都成立</a:t>
+            </a:r>
+          </a:p>
+          <a:p>
+            <a:pPr algn="l">
+              <a:spcAft>
+                <a:spcPts val="600"/>
+              </a:spcAft>
+            </a:pPr>
+            <a:r>
+              <a:rPr sz="1600" b="0">
+                <a:solidFill>
+                  <a:srgbClr val="F4F7FB"/>
+                </a:solidFill>
+                <a:latin typeface="Microsoft YaHei"/>
+              </a:rPr>
+              <a:t>1  有一个真实场景</a:t>
+            </a:r>
+          </a:p>
+          <a:p>
+            <a:pPr algn="l">
+              <a:spcAft>
+                <a:spcPts val="600"/>
+              </a:spcAft>
+            </a:pPr>
+            <a:r>
+              <a:rPr sz="1600" b="0">
+                <a:solidFill>
+                  <a:srgbClr val="F4F7FB"/>
+                </a:solidFill>
+                <a:latin typeface="Microsoft YaHei"/>
+              </a:rPr>
+              <a:t>2  stor / comp / comm / sched 合在一起仍表达不了必要关系</a:t>
+            </a:r>
+          </a:p>
+          <a:p>
+            <a:pPr algn="l">
+              <a:spcAft>
+                <a:spcPts val="600"/>
+              </a:spcAft>
+            </a:pPr>
+            <a:r>
+              <a:rPr sz="1600" b="0">
+                <a:solidFill>
+                  <a:srgbClr val="F4F7FB"/>
+                </a:solidFill>
+                <a:latin typeface="Microsoft YaHei"/>
+              </a:rPr>
+              <a:t>3  不是非法输入、缺 witness，或 plan 对不上</a:t>
+            </a:r>
+          </a:p>
+          <a:p>
+            <a:pPr algn="l">
+              <a:spcAft>
+                <a:spcPts val="600"/>
+              </a:spcAft>
+            </a:pPr>
+            <a:r>
+              <a:rPr sz="1600" b="0">
+                <a:solidFill>
+                  <a:srgbClr val="F4F7FB"/>
+                </a:solidFill>
+                <a:latin typeface="Microsoft YaHei"/>
+              </a:rPr>
+              <a:t>4  然后才提议新合同</a:t>
+            </a:r>
+          </a:p>
+          <a:p>
+            <a:pPr algn="l">
+              <a:spcAft>
+                <a:spcPts val="600"/>
+              </a:spcAft>
+            </a:pPr>
+            <a:r>
+              <a:rPr sz="1400" b="0">
+                <a:solidFill>
+                  <a:srgbClr val="A8B3C7"/>
+                </a:solidFill>
+                <a:latin typeface="Microsoft YaHei"/>
+              </a:rPr>
+              <a:t>规则写在 empirical-semantic-boundary-v1.md</a:t>
+            </a:r>
+          </a:p>
+        </p:txBody>
+      </p:sp>
+      <p:sp>
+        <p:nvSpPr>
+          <p:cNvPr id="11" name="TextBox 10"/>
+          <p:cNvSpPr txBox="1"/>
+          <p:nvPr/>
+        </p:nvSpPr>
+        <p:spPr>
+          <a:xfrm>
+            <a:off x="7635240" y="1536192"/>
+            <a:ext cx="3931920" cy="3749039"/>
+          </a:xfrm>
+          <a:prstGeom prst="rect">
+            <a:avLst/>
+          </a:prstGeom>
+          <a:noFill/>
+        </p:spPr>
+        <p:txBody>
+          <a:bodyPr wrap="square">
+            <a:spAutoFit/>
+          </a:bodyPr>
+          <a:lstStyle/>
+          <a:p>
+            <a:pPr algn="l">
+              <a:spcAft>
+                <a:spcPts val="600"/>
+              </a:spcAft>
+            </a:pPr>
+            <a:r>
+              <a:rPr sz="1600" b="1">
+                <a:solidFill>
+                  <a:srgbClr val="E7C27A"/>
+                </a:solidFill>
+                <a:latin typeface="Microsoft YaHei"/>
+              </a:rPr>
+              <a:t>这些不是开刀的理由</a:t>
+            </a:r>
+          </a:p>
+          <a:p>
+            <a:pPr algn="l">
+              <a:spcAft>
+                <a:spcPts val="600"/>
+              </a:spcAft>
+            </a:pPr>
+            <a:r>
+              <a:rPr sz="1500" b="0">
+                <a:solidFill>
+                  <a:srgbClr val="F4F7FB"/>
+                </a:solidFill>
+                <a:latin typeface="Microsoft YaHei"/>
+              </a:rPr>
+              <a:t>再来一个 collective</a:t>
+            </a:r>
+          </a:p>
+          <a:p>
+            <a:pPr algn="l">
+              <a:spcAft>
+                <a:spcPts val="600"/>
+              </a:spcAft>
+            </a:pPr>
+            <a:r>
+              <a:rPr sz="1500" b="0">
+                <a:solidFill>
+                  <a:srgbClr val="F4F7FB"/>
+                </a:solidFill>
+                <a:latin typeface="Microsoft YaHei"/>
+              </a:rPr>
+              <a:t>场景超出 W0-3/2</a:t>
+            </a:r>
+          </a:p>
+          <a:p>
+            <a:pPr algn="l">
+              <a:spcAft>
+                <a:spcPts val="600"/>
+              </a:spcAft>
+            </a:pPr>
+            <a:r>
+              <a:rPr sz="1500" b="0">
+                <a:solidFill>
+                  <a:srgbClr val="F4F7FB"/>
+                </a:solidFill>
+                <a:latin typeface="Microsoft YaHei"/>
+              </a:rPr>
+              <a:t>routing dialect</a:t>
+            </a:r>
+          </a:p>
+          <a:p>
+            <a:pPr algn="l">
+              <a:spcAft>
+                <a:spcPts val="600"/>
+              </a:spcAft>
+            </a:pPr>
+            <a:r>
+              <a:rPr sz="1500" b="0">
+                <a:solidFill>
+                  <a:srgbClr val="F4F7FB"/>
+                </a:solidFill>
+                <a:latin typeface="Microsoft YaHei"/>
+              </a:rPr>
+              <a:t>新的 HB 规则</a:t>
+            </a:r>
+          </a:p>
+          <a:p>
+            <a:pPr algn="l">
+              <a:spcAft>
+                <a:spcPts val="600"/>
+              </a:spcAft>
+            </a:pPr>
+            <a:r>
+              <a:rPr sz="1500" b="0">
+                <a:solidFill>
+                  <a:srgbClr val="F4F7FB"/>
+                </a:solidFill>
+                <a:latin typeface="Microsoft YaHei"/>
+              </a:rPr>
+              <a:t>Search / 通用改写</a:t>
+            </a:r>
+          </a:p>
+          <a:p>
+            <a:pPr algn="l">
+              <a:spcAft>
+                <a:spcPts val="600"/>
+              </a:spcAft>
+            </a:pPr>
+            <a:r>
+              <a:rPr sz="1500" b="0">
+                <a:solidFill>
+                  <a:srgbClr val="F4F7FB"/>
+                </a:solidFill>
+                <a:latin typeface="Microsoft YaHei"/>
+              </a:rPr>
+              <a:t>一次性能测量</a:t>
+            </a:r>
+          </a:p>
+        </p:txBody>
+      </p:sp>
+      <p:sp>
+        <p:nvSpPr>
+          <p:cNvPr id="12" name="TextBox 11"/>
+          <p:cNvSpPr txBox="1"/>
+          <p:nvPr/>
+        </p:nvSpPr>
+        <p:spPr>
+          <a:xfrm>
+            <a:off x="438912" y="5669280"/>
+            <a:ext cx="11155680" cy="822960"/>
+          </a:xfrm>
+          <a:prstGeom prst="rect">
+            <a:avLst/>
+          </a:prstGeom>
+          <a:noFill/>
+        </p:spPr>
+        <p:txBody>
+          <a:bodyPr wrap="square">
+            <a:spAutoFit/>
+          </a:bodyPr>
+          <a:lstStyle/>
+          <a:p>
+            <a:pPr algn="l">
+              <a:spcAft>
+                <a:spcPts val="600"/>
+              </a:spcAft>
+            </a:pPr>
+            <a:r>
+              <a:rPr sz="1500" b="0">
+                <a:solidFill>
+                  <a:srgbClr val="A8B3C7"/>
+                </a:solidFill>
+                <a:latin typeface="Microsoft YaHei"/>
+              </a:rPr>
+              <a:t>复核：python3 runtime/record_goal_alignment.py --print-goal-alignment</a:t>
+            </a:r>
+          </a:p>
+          <a:p>
+            <a:pPr algn="l">
+              <a:spcAft>
+                <a:spcPts val="600"/>
+              </a:spcAft>
+            </a:pPr>
+            <a:r>
+              <a:rPr sz="1500" b="0">
+                <a:solidFill>
+                  <a:srgbClr val="A8B3C7"/>
+                </a:solidFill>
+                <a:latin typeface="Microsoft YaHei"/>
+              </a:rPr>
+              <a:t>语义基线 36fd6fd 不因这三页改变。next_cut = NOT OPENED</a:t>
             </a:r>
           </a:p>
         </p:txBody>

</xml_diff>